<commit_message>
feat(generate-comparison-pptx): enforce template usage and add runtime guards
- Add runtime guard to prevent execution from skill folder template
- Require script execution from .olaf/work/presentations/<name>/ output folder
- Add layout resolution helpers: get_cover_layout(), get_title_only_layout()
- Replace hardcoded layout indices with name-based layout resolution
- Add header() helper with automatic title placeholder usage and fallback
- Remove inline reference script from SKILL.md, reference
</commit_message>
<xml_diff>
--- a/skills/generate-comparison-pptx/scripts/template.pptx
+++ b/skills/generate-comparison-pptx/scripts/template.pptx
@@ -126,7 +126,7 @@
 
 <file path=ppt/slideLayouts/slideLayout1.xml><?xml version="1.0" encoding="utf-8"?>
 <p:sldLayout xmlns:a="http://schemas.openxmlformats.org/drawingml/2006/main" xmlns:r="http://schemas.openxmlformats.org/officeDocument/2006/relationships" xmlns:p="http://schemas.openxmlformats.org/presentationml/2006/main" preserve="1">
-  <p:cSld name="Cover 2 Dark Sky Vivid Sky wordmark">
+  <p:cSld name="Cover slide">
     <p:bg>
       <p:bgPr>
         <a:solidFill>
@@ -1090,14 +1090,14 @@
           </a:ln>
           <a:extLst>
             <a:ext uri="{909E8E84-426E-40dd-AFC4-6F175D3DCCD1}">
-              <a14:hiddenFill xmlns:a14="http://schemas.microsoft.com/office/drawing/2010/main" xmlns="">
+              <a14:hiddenFill xmlns="" xmlns:a14="http://schemas.microsoft.com/office/drawing/2010/main">
                 <a:solidFill>
                   <a:srgbClr val="FFFFFF"/>
                 </a:solidFill>
               </a14:hiddenFill>
             </a:ext>
             <a:ext uri="{91240B29-F687-4f45-9708-019B960494DF}">
-              <a14:hiddenLine xmlns:a14="http://schemas.microsoft.com/office/drawing/2010/main" xmlns="" w="9525">
+              <a14:hiddenLine xmlns="" xmlns:a14="http://schemas.microsoft.com/office/drawing/2010/main" w="9525">
                 <a:solidFill>
                   <a:srgbClr val="000000"/>
                 </a:solidFill>
@@ -1452,7 +1452,7 @@
           <a:p>
             <a:fld id="{5BCAD085-E8A6-8845-BD4E-CB4CCA059FC4}" type="datetimeFigureOut">
               <a:rPr lang="en-US" smtClean="0"/>
-              <a:t>2/22/2026</a:t>
+              <a:t>2/24/2026</a:t>
             </a:fld>
             <a:endParaRPr lang="en-US"/>
           </a:p>
@@ -5759,14 +5759,14 @@
           </a:ln>
           <a:extLst>
             <a:ext uri="{909E8E84-426E-40dd-AFC4-6F175D3DCCD1}">
-              <a14:hiddenFill xmlns="" xmlns:a14="http://schemas.microsoft.com/office/drawing/2010/main">
+              <a14:hiddenFill xmlns:a14="http://schemas.microsoft.com/office/drawing/2010/main" xmlns="">
                 <a:solidFill>
                   <a:srgbClr val="FFFFFF"/>
                 </a:solidFill>
               </a14:hiddenFill>
             </a:ext>
             <a:ext uri="{91240B29-F687-4f45-9708-019B960494DF}">
-              <a14:hiddenLine xmlns="" xmlns:a14="http://schemas.microsoft.com/office/drawing/2010/main" w="9525">
+              <a14:hiddenLine xmlns:a14="http://schemas.microsoft.com/office/drawing/2010/main" xmlns="" w="9525">
                 <a:solidFill>
                   <a:srgbClr val="000000"/>
                 </a:solidFill>
@@ -10240,14 +10240,14 @@
           </a:ln>
           <a:extLst>
             <a:ext uri="{909E8E84-426E-40dd-AFC4-6F175D3DCCD1}">
-              <a14:hiddenFill xmlns:a14="http://schemas.microsoft.com/office/drawing/2010/main" xmlns="">
+              <a14:hiddenFill xmlns="" xmlns:a14="http://schemas.microsoft.com/office/drawing/2010/main">
                 <a:solidFill>
                   <a:srgbClr val="FFFFFF"/>
                 </a:solidFill>
               </a14:hiddenFill>
             </a:ext>
             <a:ext uri="{91240B29-F687-4f45-9708-019B960494DF}">
-              <a14:hiddenLine xmlns:a14="http://schemas.microsoft.com/office/drawing/2010/main" xmlns="" w="9525">
+              <a14:hiddenLine xmlns="" xmlns:a14="http://schemas.microsoft.com/office/drawing/2010/main" w="9525">
                 <a:solidFill>
                   <a:srgbClr val="000000"/>
                 </a:solidFill>
@@ -14920,14 +14920,14 @@
           </a:ln>
           <a:extLst>
             <a:ext uri="{909E8E84-426E-40dd-AFC4-6F175D3DCCD1}">
-              <a14:hiddenFill xmlns:a14="http://schemas.microsoft.com/office/drawing/2010/main" xmlns="">
+              <a14:hiddenFill xmlns="" xmlns:a14="http://schemas.microsoft.com/office/drawing/2010/main">
                 <a:solidFill>
                   <a:srgbClr val="FFFFFF"/>
                 </a:solidFill>
               </a14:hiddenFill>
             </a:ext>
             <a:ext uri="{91240B29-F687-4f45-9708-019B960494DF}">
-              <a14:hiddenLine xmlns:a14="http://schemas.microsoft.com/office/drawing/2010/main" xmlns="" w="9525">
+              <a14:hiddenLine xmlns="" xmlns:a14="http://schemas.microsoft.com/office/drawing/2010/main" w="9525">
                 <a:solidFill>
                   <a:srgbClr val="000000"/>
                 </a:solidFill>
@@ -19991,14 +19991,14 @@
           </a:ln>
           <a:extLst>
             <a:ext uri="{909E8E84-426E-40dd-AFC4-6F175D3DCCD1}">
-              <a14:hiddenFill xmlns:a14="http://schemas.microsoft.com/office/drawing/2010/main" xmlns="">
+              <a14:hiddenFill xmlns="" xmlns:a14="http://schemas.microsoft.com/office/drawing/2010/main">
                 <a:solidFill>
                   <a:srgbClr val="FFFFFF"/>
                 </a:solidFill>
               </a14:hiddenFill>
             </a:ext>
             <a:ext uri="{91240B29-F687-4f45-9708-019B960494DF}">
-              <a14:hiddenLine xmlns:a14="http://schemas.microsoft.com/office/drawing/2010/main" xmlns="" w="9525">
+              <a14:hiddenLine xmlns="" xmlns:a14="http://schemas.microsoft.com/office/drawing/2010/main" w="9525">
                 <a:solidFill>
                   <a:srgbClr val="000000"/>
                 </a:solidFill>

</xml_diff>